<commit_message>
Add F3/F4 figures, rebuild pptx to 25 slides, track pptx_figures
- da_methods/.gitignore: allow pptx_figures/*.png (unblock DA figures
  from the blanket *.png ignore)
- da_methods/pptx_figures/: add all 26 presentation figures including
  8 new F3/F4 evaluation figures (error decay pooled/by-regime, ensemble
  vs USGS, two-panel)
- da_methods/build_pptx.py: add slide_f3_lead_decay, slide_f3_ensemble,
  slide_f4_lead_decay, slide_f4_ensemble; correct F2 KGE in Helene slide
  subtitle; update all_figs list; 21 → 25 slides
- da_methods/EXPERIMENTS.md: completeness matrix, server paths, and
  results summary updated with F3/F4 NSE columns and final metrics

Co-Authored-By: Claude Sonnet 4.6 <noreply@anthropic.com>
</commit_message>
<xml_diff>
--- a/da_methods/helene_da_results.pptx
+++ b/da_methods/helene_da_results.pptx
@@ -26,6 +26,10 @@
     <p:sldId id="274" r:id="rId25"/>
     <p:sldId id="275" r:id="rId26"/>
     <p:sldId id="276" r:id="rId27"/>
+    <p:sldId id="277" r:id="rId28"/>
+    <p:sldId id="278" r:id="rId29"/>
+    <p:sldId id="279" r:id="rId30"/>
+    <p:sldId id="280" r:id="rId31"/>
   </p:sldIdLst>
   <p:sldSz cx="12191695" cy="6858000" type="screen4x3"/>
   <p:notesSz cx="6858000" cy="9144000"/>
@@ -5114,7 +5118,7 @@
                   <a:srgbClr val="E69F00"/>
                 </a:solidFill>
               </a:rPr>
-              <a:t>F1 KGE=0.213 · F3 KGE=0.189 · F4 KGE=0.132  |  Vrugt keeps DA active at high flows</a:t>
+              <a:t>F1 KGE=0.213 · F2 KGE=0.439 · F3 KGE=0.189 · F4 KGE=0.132  |  Fixed R=0.07 best at peak</a:t>
             </a:r>
           </a:p>
         </p:txBody>
@@ -5172,7 +5176,7 @@
                   <a:srgbClr val="E69F00"/>
                 </a:solidFill>
               </a:rPr>
-              <a:t>Direct σ²_krig (F4) worst during Helene — large kriging variance weakens DA exactly when model needs correction most</a:t>
+              <a:t>Fixed R=0.07 (F2) keeps Kalman gain high at peak — Vrugt inflates R at high flows, dampening DA updates</a:t>
             </a:r>
           </a:p>
         </p:txBody>
@@ -5820,6 +5824,786 @@
                   <a:srgbClr val="FFFFFF"/>
                 </a:solidFill>
               </a:rPr>
+              <a:t>F3: Forecast Error Decay — Dynamic Vrugt Seeded (seed=42)</a:t>
+            </a:r>
+          </a:p>
+        </p:txBody>
+      </p:sp>
+      <p:sp>
+        <p:nvSpPr>
+          <p:cNvPr id="4" name="TextBox 3"/>
+          <p:cNvSpPr txBox="1"/>
+          <p:nvPr/>
+        </p:nvSpPr>
+        <p:spPr>
+          <a:xfrm>
+            <a:off x="274320" y="594360"/>
+            <a:ext cx="11643055" cy="320040"/>
+          </a:xfrm>
+          <a:prstGeom prst="rect">
+            <a:avLst/>
+          </a:prstGeom>
+          <a:noFill/>
+        </p:spPr>
+        <p:txBody>
+          <a:bodyPr wrap="square">
+            <a:spAutoFit/>
+          </a:bodyPr>
+          <a:lstStyle/>
+          <a:p>
+            <a:pPr algn="l"/>
+            <a:r>
+              <a:rPr sz="1300" b="0">
+                <a:solidFill>
+                  <a:srgbClr val="E69F00"/>
+                </a:solidFill>
+              </a:rPr>
+              <a:t>R = (0.10·y)² + 0.001·σ²_krig  |  Pooled across all regimes  |  Helene window</a:t>
+            </a:r>
+          </a:p>
+        </p:txBody>
+      </p:sp>
+      <p:pic>
+        <p:nvPicPr>
+          <p:cNvPr id="5" name="Picture 4" descr="f3_lead_time_decay_gauge_pooled.png"/>
+          <p:cNvPicPr>
+            <a:picLocks noChangeAspect="1"/>
+          </p:cNvPicPr>
+          <p:nvPr/>
+        </p:nvPicPr>
+        <p:blipFill>
+          <a:blip r:embed="rId2"/>
+          <a:stretch>
+            <a:fillRect/>
+          </a:stretch>
+        </p:blipFill>
+        <p:spPr>
+          <a:xfrm>
+            <a:off x="274320" y="1005840"/>
+            <a:ext cx="11612880" cy="11546898"/>
+          </a:xfrm>
+          <a:prstGeom prst="rect">
+            <a:avLst/>
+          </a:prstGeom>
+        </p:spPr>
+      </p:pic>
+      <p:sp>
+        <p:nvSpPr>
+          <p:cNvPr id="6" name="TextBox 5"/>
+          <p:cNvSpPr txBox="1"/>
+          <p:nvPr/>
+        </p:nvSpPr>
+        <p:spPr>
+          <a:xfrm>
+            <a:off x="274320" y="6263640"/>
+            <a:ext cx="11612880" cy="365760"/>
+          </a:xfrm>
+          <a:prstGeom prst="rect">
+            <a:avLst/>
+          </a:prstGeom>
+          <a:noFill/>
+        </p:spPr>
+        <p:txBody>
+          <a:bodyPr wrap="square">
+            <a:spAutoFit/>
+          </a:bodyPr>
+          <a:lstStyle/>
+          <a:p>
+            <a:pPr algn="ctr"/>
+            <a:r>
+              <a:rPr sz="1100" b="0">
+                <a:solidFill>
+                  <a:srgbClr val="E69F00"/>
+                </a:solidFill>
+              </a:rPr>
+              <a:t>F3 KGE=+0.261 (full period)  |  Helene KGE=+0.189  |  Peak 693.8 m³/s (37% of USGS 1885.7)</a:t>
+            </a:r>
+          </a:p>
+        </p:txBody>
+      </p:sp>
+    </p:spTree>
+  </p:cSld>
+  <p:clrMapOvr>
+    <a:masterClrMapping/>
+  </p:clrMapOvr>
+</p:sld>
+</file>
+
+<file path=ppt/slides/slide21.xml><?xml version="1.0" encoding="utf-8"?>
+<p:sld xmlns:a="http://schemas.openxmlformats.org/drawingml/2006/main" xmlns:p="http://schemas.openxmlformats.org/presentationml/2006/main" xmlns:r="http://schemas.openxmlformats.org/officeDocument/2006/relationships">
+  <p:cSld>
+    <p:bg>
+      <p:bgPr>
+        <a:solidFill>
+          <a:srgbClr val="1A1A2E"/>
+        </a:solidFill>
+        <a:effectLst/>
+      </p:bgPr>
+    </p:bg>
+    <p:spTree>
+      <p:nvGrpSpPr>
+        <p:cNvPr id="1" name=""/>
+        <p:cNvGrpSpPr/>
+        <p:nvPr/>
+      </p:nvGrpSpPr>
+      <p:grpSpPr/>
+      <p:sp>
+        <p:nvSpPr>
+          <p:cNvPr id="2" name="Rectangle 1"/>
+          <p:cNvSpPr/>
+          <p:nvPr/>
+        </p:nvSpPr>
+        <p:spPr>
+          <a:xfrm>
+            <a:off x="0" y="0"/>
+            <a:ext cx="12191695" cy="914400"/>
+          </a:xfrm>
+          <a:prstGeom prst="rect">
+            <a:avLst/>
+          </a:prstGeom>
+          <a:solidFill>
+            <a:srgbClr val="0F3C78"/>
+          </a:solidFill>
+          <a:ln>
+            <a:noFill/>
+          </a:ln>
+        </p:spPr>
+        <p:style>
+          <a:lnRef idx="1">
+            <a:schemeClr val="accent1"/>
+          </a:lnRef>
+          <a:fillRef idx="3">
+            <a:schemeClr val="accent1"/>
+          </a:fillRef>
+          <a:effectRef idx="2">
+            <a:schemeClr val="accent1"/>
+          </a:effectRef>
+          <a:fontRef idx="minor">
+            <a:schemeClr val="lt1"/>
+          </a:fontRef>
+        </p:style>
+        <p:txBody>
+          <a:bodyPr rtlCol="0" anchor="ctr"/>
+          <a:lstStyle/>
+          <a:p>
+            <a:pPr algn="ctr"/>
+          </a:p>
+        </p:txBody>
+      </p:sp>
+      <p:sp>
+        <p:nvSpPr>
+          <p:cNvPr id="3" name="TextBox 2"/>
+          <p:cNvSpPr txBox="1"/>
+          <p:nvPr/>
+        </p:nvSpPr>
+        <p:spPr>
+          <a:xfrm>
+            <a:off x="274320" y="45720"/>
+            <a:ext cx="11643055" cy="594360"/>
+          </a:xfrm>
+          <a:prstGeom prst="rect">
+            <a:avLst/>
+          </a:prstGeom>
+          <a:noFill/>
+        </p:spPr>
+        <p:txBody>
+          <a:bodyPr wrap="square">
+            <a:spAutoFit/>
+          </a:bodyPr>
+          <a:lstStyle/>
+          <a:p>
+            <a:pPr algn="l"/>
+            <a:r>
+              <a:rPr sz="2400" b="1">
+                <a:solidFill>
+                  <a:srgbClr val="FFFFFF"/>
+                </a:solidFill>
+              </a:rPr>
+              <a:t>F3: Ensemble Routing at Gauge — Dynamic Vrugt Seeded</a:t>
+            </a:r>
+          </a:p>
+        </p:txBody>
+      </p:sp>
+      <p:sp>
+        <p:nvSpPr>
+          <p:cNvPr id="4" name="TextBox 3"/>
+          <p:cNvSpPr txBox="1"/>
+          <p:nvPr/>
+        </p:nvSpPr>
+        <p:spPr>
+          <a:xfrm>
+            <a:off x="274320" y="594360"/>
+            <a:ext cx="11643055" cy="320040"/>
+          </a:xfrm>
+          <a:prstGeom prst="rect">
+            <a:avLst/>
+          </a:prstGeom>
+          <a:noFill/>
+        </p:spPr>
+        <p:txBody>
+          <a:bodyPr wrap="square">
+            <a:spAutoFit/>
+          </a:bodyPr>
+          <a:lstStyle/>
+          <a:p>
+            <a:pPr algn="l"/>
+            <a:r>
+              <a:rPr sz="1300" b="0">
+                <a:solidFill>
+                  <a:srgbClr val="E69F00"/>
+                </a:solidFill>
+              </a:rPr>
+              <a:t>600-member crossed ensemble  |  5–95 pct band + median vs USGS  |  Helene window</a:t>
+            </a:r>
+          </a:p>
+        </p:txBody>
+      </p:sp>
+      <p:pic>
+        <p:nvPicPr>
+          <p:cNvPr id="5" name="Picture 4" descr="f3_helene_ensemble_twopanel.png"/>
+          <p:cNvPicPr>
+            <a:picLocks noChangeAspect="1"/>
+          </p:cNvPicPr>
+          <p:nvPr/>
+        </p:nvPicPr>
+        <p:blipFill>
+          <a:blip r:embed="rId2"/>
+          <a:stretch>
+            <a:fillRect/>
+          </a:stretch>
+        </p:blipFill>
+        <p:spPr>
+          <a:xfrm>
+            <a:off x="274320" y="1005840"/>
+            <a:ext cx="11612880" cy="7433581"/>
+          </a:xfrm>
+          <a:prstGeom prst="rect">
+            <a:avLst/>
+          </a:prstGeom>
+        </p:spPr>
+      </p:pic>
+      <p:sp>
+        <p:nvSpPr>
+          <p:cNvPr id="6" name="TextBox 5"/>
+          <p:cNvSpPr txBox="1"/>
+          <p:nvPr/>
+        </p:nvSpPr>
+        <p:spPr>
+          <a:xfrm>
+            <a:off x="274320" y="6263640"/>
+            <a:ext cx="11612880" cy="365760"/>
+          </a:xfrm>
+          <a:prstGeom prst="rect">
+            <a:avLst/>
+          </a:prstGeom>
+          <a:noFill/>
+        </p:spPr>
+        <p:txBody>
+          <a:bodyPr wrap="square">
+            <a:spAutoFit/>
+          </a:bodyPr>
+          <a:lstStyle/>
+          <a:p>
+            <a:pPr algn="ctr"/>
+            <a:r>
+              <a:rPr sz="1100" b="0">
+                <a:solidFill>
+                  <a:srgbClr val="E69F00"/>
+                </a:solidFill>
+              </a:rPr>
+              <a:t>p95=759 m³/s, p50=484 m³/s  |  Vrugt R grows at high flows, narrowing spread near peak</a:t>
+            </a:r>
+          </a:p>
+        </p:txBody>
+      </p:sp>
+    </p:spTree>
+  </p:cSld>
+  <p:clrMapOvr>
+    <a:masterClrMapping/>
+  </p:clrMapOvr>
+</p:sld>
+</file>
+
+<file path=ppt/slides/slide22.xml><?xml version="1.0" encoding="utf-8"?>
+<p:sld xmlns:a="http://schemas.openxmlformats.org/drawingml/2006/main" xmlns:p="http://schemas.openxmlformats.org/presentationml/2006/main" xmlns:r="http://schemas.openxmlformats.org/officeDocument/2006/relationships">
+  <p:cSld>
+    <p:bg>
+      <p:bgPr>
+        <a:solidFill>
+          <a:srgbClr val="1A1A2E"/>
+        </a:solidFill>
+        <a:effectLst/>
+      </p:bgPr>
+    </p:bg>
+    <p:spTree>
+      <p:nvGrpSpPr>
+        <p:cNvPr id="1" name=""/>
+        <p:cNvGrpSpPr/>
+        <p:nvPr/>
+      </p:nvGrpSpPr>
+      <p:grpSpPr/>
+      <p:sp>
+        <p:nvSpPr>
+          <p:cNvPr id="2" name="Rectangle 1"/>
+          <p:cNvSpPr/>
+          <p:nvPr/>
+        </p:nvSpPr>
+        <p:spPr>
+          <a:xfrm>
+            <a:off x="0" y="0"/>
+            <a:ext cx="12191695" cy="914400"/>
+          </a:xfrm>
+          <a:prstGeom prst="rect">
+            <a:avLst/>
+          </a:prstGeom>
+          <a:solidFill>
+            <a:srgbClr val="0F3C78"/>
+          </a:solidFill>
+          <a:ln>
+            <a:noFill/>
+          </a:ln>
+        </p:spPr>
+        <p:style>
+          <a:lnRef idx="1">
+            <a:schemeClr val="accent1"/>
+          </a:lnRef>
+          <a:fillRef idx="3">
+            <a:schemeClr val="accent1"/>
+          </a:fillRef>
+          <a:effectRef idx="2">
+            <a:schemeClr val="accent1"/>
+          </a:effectRef>
+          <a:fontRef idx="minor">
+            <a:schemeClr val="lt1"/>
+          </a:fontRef>
+        </p:style>
+        <p:txBody>
+          <a:bodyPr rtlCol="0" anchor="ctr"/>
+          <a:lstStyle/>
+          <a:p>
+            <a:pPr algn="ctr"/>
+          </a:p>
+        </p:txBody>
+      </p:sp>
+      <p:sp>
+        <p:nvSpPr>
+          <p:cNvPr id="3" name="TextBox 2"/>
+          <p:cNvSpPr txBox="1"/>
+          <p:nvPr/>
+        </p:nvSpPr>
+        <p:spPr>
+          <a:xfrm>
+            <a:off x="274320" y="45720"/>
+            <a:ext cx="11643055" cy="594360"/>
+          </a:xfrm>
+          <a:prstGeom prst="rect">
+            <a:avLst/>
+          </a:prstGeom>
+          <a:noFill/>
+        </p:spPr>
+        <p:txBody>
+          <a:bodyPr wrap="square">
+            <a:spAutoFit/>
+          </a:bodyPr>
+          <a:lstStyle/>
+          <a:p>
+            <a:pPr algn="l"/>
+            <a:r>
+              <a:rPr sz="2400" b="1">
+                <a:solidFill>
+                  <a:srgbClr val="FFFFFF"/>
+                </a:solidFill>
+              </a:rPr>
+              <a:t>F4: Forecast Error Decay — Direct σ²_krig (seed=42)</a:t>
+            </a:r>
+          </a:p>
+        </p:txBody>
+      </p:sp>
+      <p:sp>
+        <p:nvSpPr>
+          <p:cNvPr id="4" name="TextBox 3"/>
+          <p:cNvSpPr txBox="1"/>
+          <p:nvPr/>
+        </p:nvSpPr>
+        <p:spPr>
+          <a:xfrm>
+            <a:off x="274320" y="594360"/>
+            <a:ext cx="11643055" cy="320040"/>
+          </a:xfrm>
+          <a:prstGeom prst="rect">
+            <a:avLst/>
+          </a:prstGeom>
+          <a:noFill/>
+        </p:spPr>
+        <p:txBody>
+          <a:bodyPr wrap="square">
+            <a:spAutoFit/>
+          </a:bodyPr>
+          <a:lstStyle/>
+          <a:p>
+            <a:pPr algn="l"/>
+            <a:r>
+              <a:rPr sz="1300" b="0">
+                <a:solidFill>
+                  <a:srgbClr val="E69F00"/>
+                </a:solidFill>
+              </a:rPr>
+              <a:t>R = σ²_krig directly (no Vrugt formula)  |  Pooled across all regimes</a:t>
+            </a:r>
+          </a:p>
+        </p:txBody>
+      </p:sp>
+      <p:pic>
+        <p:nvPicPr>
+          <p:cNvPr id="5" name="Picture 4" descr="f4_lead_time_decay_gauge_pooled.png"/>
+          <p:cNvPicPr>
+            <a:picLocks noChangeAspect="1"/>
+          </p:cNvPicPr>
+          <p:nvPr/>
+        </p:nvPicPr>
+        <p:blipFill>
+          <a:blip r:embed="rId2"/>
+          <a:stretch>
+            <a:fillRect/>
+          </a:stretch>
+        </p:blipFill>
+        <p:spPr>
+          <a:xfrm>
+            <a:off x="274320" y="1005840"/>
+            <a:ext cx="11612880" cy="11546898"/>
+          </a:xfrm>
+          <a:prstGeom prst="rect">
+            <a:avLst/>
+          </a:prstGeom>
+        </p:spPr>
+      </p:pic>
+      <p:sp>
+        <p:nvSpPr>
+          <p:cNvPr id="6" name="TextBox 5"/>
+          <p:cNvSpPr txBox="1"/>
+          <p:nvPr/>
+        </p:nvSpPr>
+        <p:spPr>
+          <a:xfrm>
+            <a:off x="274320" y="6263640"/>
+            <a:ext cx="11612880" cy="365760"/>
+          </a:xfrm>
+          <a:prstGeom prst="rect">
+            <a:avLst/>
+          </a:prstGeom>
+          <a:noFill/>
+        </p:spPr>
+        <p:txBody>
+          <a:bodyPr wrap="square">
+            <a:spAutoFit/>
+          </a:bodyPr>
+          <a:lstStyle/>
+          <a:p>
+            <a:pPr algn="ctr"/>
+            <a:r>
+              <a:rPr sz="1100" b="0">
+                <a:solidFill>
+                  <a:srgbClr val="E69F00"/>
+                </a:solidFill>
+              </a:rPr>
+              <a:t>F4 KGE=+0.200 (full period)  |  Helene KGE=+0.132  |  Peak 667.9 m³/s (35% of USGS 1885.7)</a:t>
+            </a:r>
+          </a:p>
+        </p:txBody>
+      </p:sp>
+    </p:spTree>
+  </p:cSld>
+  <p:clrMapOvr>
+    <a:masterClrMapping/>
+  </p:clrMapOvr>
+</p:sld>
+</file>
+
+<file path=ppt/slides/slide23.xml><?xml version="1.0" encoding="utf-8"?>
+<p:sld xmlns:a="http://schemas.openxmlformats.org/drawingml/2006/main" xmlns:p="http://schemas.openxmlformats.org/presentationml/2006/main" xmlns:r="http://schemas.openxmlformats.org/officeDocument/2006/relationships">
+  <p:cSld>
+    <p:bg>
+      <p:bgPr>
+        <a:solidFill>
+          <a:srgbClr val="1A1A2E"/>
+        </a:solidFill>
+        <a:effectLst/>
+      </p:bgPr>
+    </p:bg>
+    <p:spTree>
+      <p:nvGrpSpPr>
+        <p:cNvPr id="1" name=""/>
+        <p:cNvGrpSpPr/>
+        <p:nvPr/>
+      </p:nvGrpSpPr>
+      <p:grpSpPr/>
+      <p:sp>
+        <p:nvSpPr>
+          <p:cNvPr id="2" name="Rectangle 1"/>
+          <p:cNvSpPr/>
+          <p:nvPr/>
+        </p:nvSpPr>
+        <p:spPr>
+          <a:xfrm>
+            <a:off x="0" y="0"/>
+            <a:ext cx="12191695" cy="914400"/>
+          </a:xfrm>
+          <a:prstGeom prst="rect">
+            <a:avLst/>
+          </a:prstGeom>
+          <a:solidFill>
+            <a:srgbClr val="0F3C78"/>
+          </a:solidFill>
+          <a:ln>
+            <a:noFill/>
+          </a:ln>
+        </p:spPr>
+        <p:style>
+          <a:lnRef idx="1">
+            <a:schemeClr val="accent1"/>
+          </a:lnRef>
+          <a:fillRef idx="3">
+            <a:schemeClr val="accent1"/>
+          </a:fillRef>
+          <a:effectRef idx="2">
+            <a:schemeClr val="accent1"/>
+          </a:effectRef>
+          <a:fontRef idx="minor">
+            <a:schemeClr val="lt1"/>
+          </a:fontRef>
+        </p:style>
+        <p:txBody>
+          <a:bodyPr rtlCol="0" anchor="ctr"/>
+          <a:lstStyle/>
+          <a:p>
+            <a:pPr algn="ctr"/>
+          </a:p>
+        </p:txBody>
+      </p:sp>
+      <p:sp>
+        <p:nvSpPr>
+          <p:cNvPr id="3" name="TextBox 2"/>
+          <p:cNvSpPr txBox="1"/>
+          <p:nvPr/>
+        </p:nvSpPr>
+        <p:spPr>
+          <a:xfrm>
+            <a:off x="274320" y="45720"/>
+            <a:ext cx="11643055" cy="594360"/>
+          </a:xfrm>
+          <a:prstGeom prst="rect">
+            <a:avLst/>
+          </a:prstGeom>
+          <a:noFill/>
+        </p:spPr>
+        <p:txBody>
+          <a:bodyPr wrap="square">
+            <a:spAutoFit/>
+          </a:bodyPr>
+          <a:lstStyle/>
+          <a:p>
+            <a:pPr algn="l"/>
+            <a:r>
+              <a:rPr sz="2400" b="1">
+                <a:solidFill>
+                  <a:srgbClr val="FFFFFF"/>
+                </a:solidFill>
+              </a:rPr>
+              <a:t>F4: Ensemble Routing at Gauge — Direct σ²_krig</a:t>
+            </a:r>
+          </a:p>
+        </p:txBody>
+      </p:sp>
+      <p:sp>
+        <p:nvSpPr>
+          <p:cNvPr id="4" name="TextBox 3"/>
+          <p:cNvSpPr txBox="1"/>
+          <p:nvPr/>
+        </p:nvSpPr>
+        <p:spPr>
+          <a:xfrm>
+            <a:off x="274320" y="594360"/>
+            <a:ext cx="11643055" cy="320040"/>
+          </a:xfrm>
+          <a:prstGeom prst="rect">
+            <a:avLst/>
+          </a:prstGeom>
+          <a:noFill/>
+        </p:spPr>
+        <p:txBody>
+          <a:bodyPr wrap="square">
+            <a:spAutoFit/>
+          </a:bodyPr>
+          <a:lstStyle/>
+          <a:p>
+            <a:pPr algn="l"/>
+            <a:r>
+              <a:rPr sz="1300" b="0">
+                <a:solidFill>
+                  <a:srgbClr val="E69F00"/>
+                </a:solidFill>
+              </a:rPr>
+              <a:t>600-member crossed ensemble  |  5–95 pct band + median vs USGS  |  Helene window</a:t>
+            </a:r>
+          </a:p>
+        </p:txBody>
+      </p:sp>
+      <p:pic>
+        <p:nvPicPr>
+          <p:cNvPr id="5" name="Picture 4" descr="f4_helene_ensemble_twopanel.png"/>
+          <p:cNvPicPr>
+            <a:picLocks noChangeAspect="1"/>
+          </p:cNvPicPr>
+          <p:nvPr/>
+        </p:nvPicPr>
+        <p:blipFill>
+          <a:blip r:embed="rId2"/>
+          <a:stretch>
+            <a:fillRect/>
+          </a:stretch>
+        </p:blipFill>
+        <p:spPr>
+          <a:xfrm>
+            <a:off x="274320" y="1005840"/>
+            <a:ext cx="11612880" cy="7433581"/>
+          </a:xfrm>
+          <a:prstGeom prst="rect">
+            <a:avLst/>
+          </a:prstGeom>
+        </p:spPr>
+      </p:pic>
+      <p:sp>
+        <p:nvSpPr>
+          <p:cNvPr id="6" name="TextBox 5"/>
+          <p:cNvSpPr txBox="1"/>
+          <p:nvPr/>
+        </p:nvSpPr>
+        <p:spPr>
+          <a:xfrm>
+            <a:off x="274320" y="6263640"/>
+            <a:ext cx="11612880" cy="365760"/>
+          </a:xfrm>
+          <a:prstGeom prst="rect">
+            <a:avLst/>
+          </a:prstGeom>
+          <a:noFill/>
+        </p:spPr>
+        <p:txBody>
+          <a:bodyPr wrap="square">
+            <a:spAutoFit/>
+          </a:bodyPr>
+          <a:lstStyle/>
+          <a:p>
+            <a:pPr algn="ctr"/>
+            <a:r>
+              <a:rPr sz="1100" b="0">
+                <a:solidFill>
+                  <a:srgbClr val="E69F00"/>
+                </a:solidFill>
+              </a:rPr>
+              <a:t>p95=744 m³/s, p50=552 m³/s  |  Large σ²_krig collapses Kalman gain — worst performer across all metrics</a:t>
+            </a:r>
+          </a:p>
+        </p:txBody>
+      </p:sp>
+    </p:spTree>
+  </p:cSld>
+  <p:clrMapOvr>
+    <a:masterClrMapping/>
+  </p:clrMapOvr>
+</p:sld>
+</file>
+
+<file path=ppt/slides/slide24.xml><?xml version="1.0" encoding="utf-8"?>
+<p:sld xmlns:a="http://schemas.openxmlformats.org/drawingml/2006/main" xmlns:p="http://schemas.openxmlformats.org/presentationml/2006/main" xmlns:r="http://schemas.openxmlformats.org/officeDocument/2006/relationships">
+  <p:cSld>
+    <p:bg>
+      <p:bgPr>
+        <a:solidFill>
+          <a:srgbClr val="1A1A2E"/>
+        </a:solidFill>
+        <a:effectLst/>
+      </p:bgPr>
+    </p:bg>
+    <p:spTree>
+      <p:nvGrpSpPr>
+        <p:cNvPr id="1" name=""/>
+        <p:cNvGrpSpPr/>
+        <p:nvPr/>
+      </p:nvGrpSpPr>
+      <p:grpSpPr/>
+      <p:sp>
+        <p:nvSpPr>
+          <p:cNvPr id="2" name="Rectangle 1"/>
+          <p:cNvSpPr/>
+          <p:nvPr/>
+        </p:nvSpPr>
+        <p:spPr>
+          <a:xfrm>
+            <a:off x="0" y="0"/>
+            <a:ext cx="12191695" cy="914400"/>
+          </a:xfrm>
+          <a:prstGeom prst="rect">
+            <a:avLst/>
+          </a:prstGeom>
+          <a:solidFill>
+            <a:srgbClr val="0F3C78"/>
+          </a:solidFill>
+          <a:ln>
+            <a:noFill/>
+          </a:ln>
+        </p:spPr>
+        <p:style>
+          <a:lnRef idx="1">
+            <a:schemeClr val="accent1"/>
+          </a:lnRef>
+          <a:fillRef idx="3">
+            <a:schemeClr val="accent1"/>
+          </a:fillRef>
+          <a:effectRef idx="2">
+            <a:schemeClr val="accent1"/>
+          </a:effectRef>
+          <a:fontRef idx="minor">
+            <a:schemeClr val="lt1"/>
+          </a:fontRef>
+        </p:style>
+        <p:txBody>
+          <a:bodyPr rtlCol="0" anchor="ctr"/>
+          <a:lstStyle/>
+          <a:p>
+            <a:pPr algn="ctr"/>
+          </a:p>
+        </p:txBody>
+      </p:sp>
+      <p:sp>
+        <p:nvSpPr>
+          <p:cNvPr id="3" name="TextBox 2"/>
+          <p:cNvSpPr txBox="1"/>
+          <p:nvPr/>
+        </p:nvSpPr>
+        <p:spPr>
+          <a:xfrm>
+            <a:off x="274320" y="45720"/>
+            <a:ext cx="11643055" cy="594360"/>
+          </a:xfrm>
+          <a:prstGeom prst="rect">
+            <a:avLst/>
+          </a:prstGeom>
+          <a:noFill/>
+        </p:spPr>
+        <p:txBody>
+          <a:bodyPr wrap="square">
+            <a:spAutoFit/>
+          </a:bodyPr>
+          <a:lstStyle/>
+          <a:p>
+            <a:pPr algn="l"/>
+            <a:r>
+              <a:rPr sz="2400" b="1">
+                <a:solidFill>
+                  <a:srgbClr val="FFFFFF"/>
+                </a:solidFill>
+              </a:rPr>
               <a:t>Sensitivity Ensemble — Spaghetti (All Catchments)</a:t>
             </a:r>
           </a:p>
@@ -5891,7 +6675,7 @@
 </p:sld>
 </file>
 
-<file path=ppt/slides/slide21.xml><?xml version="1.0" encoding="utf-8"?>
+<file path=ppt/slides/slide25.xml><?xml version="1.0" encoding="utf-8"?>
 <p:sld xmlns:a="http://schemas.openxmlformats.org/drawingml/2006/main" xmlns:p="http://schemas.openxmlformats.org/presentationml/2006/main" xmlns:r="http://schemas.openxmlformats.org/officeDocument/2006/relationships">
   <p:cSld>
     <p:bg>

</xml_diff>